<commit_message>
docs(report): cap nhat bao cao thuc tap Word, slide va thong tin mat khau ha tang cloud 24/7
- Cap nhat file Word Bao_Cao_Thuc_Tap_He_Thong_Dat_Lich_Salon_Spa.docx: bo sung lich su phat hanh tu v1.5.0 den v2.2.1, kien truc trien khai dam may 24/7 (Supabase, Render, Cloudflare Pages, Worker keepalive)

- Cap nhat Slide_Bao_Cao_He_Thong_Dat_Lich_Salon_Spa.pptx dong bo so lieu he thong

- Tao tai lieu mk/pass.docx luu tru thong tin ket noi Cloud 24/7, tai khoan Admin va huong dan tich hop Render/Cloudflare MCP

- Bo sung script keepalive va wrangler vao package.json, bo sung quy tac bo qua vao .gitignore
</commit_message>
<xml_diff>
--- a/docs/presentations/Slide_Bao_Cao_He_Thong_Dat_Lich_Salon_Spa.pptx
+++ b/docs/presentations/Slide_Bao_Cao_He_Thong_Dat_Lich_Salon_Spa.pptx
@@ -16543,7 +16543,7 @@
                 </a:solidFill>
                 <a:latin typeface="Calibri"/>
               </a:rPr>
-              <a:t>1. Trình bày</a:t>
+              <a:t>1. Trình bày (Cloud/Local)</a:t>
             </a:r>
           </a:p>
         </p:txBody>
@@ -16585,7 +16585,7 @@
                 </a:solidFill>
                 <a:latin typeface="Calibri"/>
               </a:rPr>
-              <a:t>React 18 + Vite</a:t>
+              <a:t>React 18 + Vite (Cloudflare Pages CDN)</a:t>
             </a:r>
           </a:p>
         </p:txBody>
@@ -16627,7 +16627,7 @@
                 </a:solidFill>
                 <a:latin typeface="Calibri"/>
               </a:rPr>
-              <a:t>Trang công khai và quản lý; nhận SSE để làm mới dữ liệu</a:t>
+              <a:t>Trang công khai và quản lý; nhận SSE; triển khai đám mây toàn cầu https://huongsen-salon.pages.dev</a:t>
             </a:r>
           </a:p>
         </p:txBody>
@@ -16754,7 +16754,7 @@
                 </a:solidFill>
                 <a:latin typeface="Calibri"/>
               </a:rPr>
-              <a:t>NestJS 10 Controller, DTO, Guard</a:t>
+              <a:t>NestJS 10 (Render Cloud Service)</a:t>
             </a:r>
           </a:p>
         </p:txBody>
@@ -16796,7 +16796,7 @@
                 </a:solidFill>
                 <a:latin typeface="Calibri"/>
               </a:rPr>
-              <a:t>REST/JSON; xác thực JWT; kiểm tra dữ liệu và phân quyền</a:t>
+              <a:t>REST/JSON, JWT, CORS; triển khai backend 24/7 https://salon-spa-api-93d7.onrender.com</a:t>
             </a:r>
           </a:p>
         </p:txBody>
@@ -16881,7 +16881,7 @@
                 </a:solidFill>
                 <a:latin typeface="Calibri"/>
               </a:rPr>
-              <a:t>3. Nghiệp vụ</a:t>
+              <a:t>3. Nghiệp vụ &amp; Vận hành</a:t>
             </a:r>
           </a:p>
         </p:txBody>
@@ -16923,7 +16923,7 @@
                 </a:solidFill>
                 <a:latin typeface="Calibri"/>
               </a:rPr>
-              <a:t>NestJS Service</a:t>
+              <a:t>NestJS Service + Cloudflare Worker</a:t>
             </a:r>
           </a:p>
         </p:txBody>
@@ -16965,7 +16965,7 @@
                 </a:solidFill>
                 <a:latin typeface="Calibri"/>
               </a:rPr>
-              <a:t>Tính khung giờ, ngày nghỉ, vòng đời lịch, thanh toán; phát sự kiện sau commit</a:t>
+              <a:t>Tính khung giờ, ca làm, giữ chỗ; Worker cron 10 phút giữ thức API 24/7</a:t>
             </a:r>
           </a:p>
         </p:txBody>
@@ -17092,7 +17092,7 @@
                 </a:solidFill>
                 <a:latin typeface="Calibri"/>
               </a:rPr>
-              <a:t>TypeORM Repository + PostgreSQL</a:t>
+              <a:t>TypeORM + Supabase PostgreSQL 17</a:t>
             </a:r>
           </a:p>
         </p:txBody>
@@ -17134,7 +17134,7 @@
                 </a:solidFill>
                 <a:latin typeface="Calibri"/>
               </a:rPr>
-              <a:t>Migration có phiên bản; giao dịch SERIALIZABLE, FOR UPDATE, EXCLUDE</a:t>
+              <a:t>Migration 32 bảng, Session Pooler cổng 5432, sao lưu tự động pg_dump</a:t>
             </a:r>
           </a:p>
         </p:txBody>

</xml_diff>

<commit_message>
docs: dong bo so lieu bao cao Word va slide PPT len v3.0.0 (385 Unit tests, 155 E2E)
</commit_message>
<xml_diff>
--- a/docs/presentations/Slide_Bao_Cao_He_Thong_Dat_Lich_Salon_Spa.pptx
+++ b/docs/presentations/Slide_Bao_Cao_He_Thong_Dat_Lich_Salon_Spa.pptx
@@ -974,7 +974,7 @@
           <a:lstStyle/>
           <a:p>
             <a:r>
-              <a:t>Kiểm định 06/10/2026: 168 unit test, 95 E2E trong 13 bộ, 4 test Demo đạt. Build và lint sạch. 39 story / 165 point đối chiếu Excel gốc và BACKLOG-MAPPING; test tự động không thay thế biên bản nghiệm thu thủ công của PO.</a:t>
+              <a:t>Kiểm định 16/10/2026: 385 unit test, 155 E2E trong 13 bộ, 4 test Demo đạt. Build và lint sạch. 39 story / 165 point đối chiếu Excel gốc và BACKLOG-MAPPING; test tự động không thay thế biên bản nghiệm thu thủ công của PO.</a:t>
             </a:r>
           </a:p>
         </p:txBody>
@@ -10095,7 +10095,7 @@
                 </a:solidFill>
                 <a:latin typeface="Calibri"/>
               </a:rPr>
-              <a:t>168/168</a:t>
+              <a:t>385/385</a:t>
             </a:r>
           </a:p>
         </p:txBody>
@@ -10271,7 +10271,7 @@
                 </a:solidFill>
                 <a:latin typeface="Calibri"/>
               </a:rPr>
-              <a:t>95/95</a:t>
+              <a:t>155/155</a:t>
             </a:r>
           </a:p>
         </p:txBody>
@@ -10955,7 +10955,7 @@
                 </a:solidFill>
                 <a:latin typeface="Calibri"/>
               </a:rPr>
-              <a:t>Giao diện Fresha</a:t>
+              <a:t>Fresha Luxury</a:t>
             </a:r>
           </a:p>
         </p:txBody>
@@ -11042,7 +11042,7 @@
                 </a:solidFill>
                 <a:latin typeface="Calibri"/>
               </a:rPr>
-              <a:t>27/09</a:t>
+              <a:t>02/10</a:t>
             </a:r>
           </a:p>
         </p:txBody>
@@ -11084,7 +11084,7 @@
                 </a:solidFill>
                 <a:latin typeface="Calibri"/>
               </a:rPr>
-              <a:t>v1.2.0</a:t>
+              <a:t>v1.3.0</a:t>
             </a:r>
           </a:p>
         </p:txBody>
@@ -11126,7 +11126,7 @@
                 </a:solidFill>
                 <a:latin typeface="Calibri"/>
               </a:rPr>
-              <a:t>15 + 8 lỗi Sprint 1</a:t>
+              <a:t>23 lỗi QA</a:t>
             </a:r>
           </a:p>
         </p:txBody>
@@ -11213,7 +11213,7 @@
                 </a:solidFill>
                 <a:latin typeface="Calibri"/>
               </a:rPr>
-              <a:t>28/09</a:t>
+              <a:t>06/10</a:t>
             </a:r>
           </a:p>
         </p:txBody>
@@ -11255,7 +11255,7 @@
                 </a:solidFill>
                 <a:latin typeface="Calibri"/>
               </a:rPr>
-              <a:t>v1.2.5</a:t>
+              <a:t>v1.4.0</a:t>
             </a:r>
           </a:p>
         </p:txBody>
@@ -11297,7 +11297,7 @@
                 </a:solidFill>
                 <a:latin typeface="Calibri"/>
               </a:rPr>
-              <a:t>Supervisor</a:t>
+              <a:t>11 góp ý Mentor</a:t>
             </a:r>
           </a:p>
         </p:txBody>
@@ -11384,7 +11384,7 @@
                 </a:solidFill>
                 <a:latin typeface="Calibri"/>
               </a:rPr>
-              <a:t>02/10</a:t>
+              <a:t>11/10</a:t>
             </a:r>
           </a:p>
         </p:txBody>
@@ -11426,7 +11426,7 @@
                 </a:solidFill>
                 <a:latin typeface="Calibri"/>
               </a:rPr>
-              <a:t>v1.3.0</a:t>
+              <a:t>v2.0.0</a:t>
             </a:r>
           </a:p>
         </p:txBody>
@@ -11468,7 +11468,7 @@
                 </a:solidFill>
                 <a:latin typeface="Calibri"/>
               </a:rPr>
-              <a:t>23 lỗi QA Sprint 2</a:t>
+              <a:t>AI Local</a:t>
             </a:r>
           </a:p>
         </p:txBody>
@@ -11555,7 +11555,7 @@
                 </a:solidFill>
                 <a:latin typeface="Calibri"/>
               </a:rPr>
-              <a:t>05/10</a:t>
+              <a:t>15/10</a:t>
             </a:r>
           </a:p>
         </p:txBody>
@@ -11597,7 +11597,7 @@
                 </a:solidFill>
                 <a:latin typeface="Calibri"/>
               </a:rPr>
-              <a:t>v1.3.6</a:t>
+              <a:t>v2.2.1</a:t>
             </a:r>
           </a:p>
         </p:txBody>
@@ -11639,7 +11639,7 @@
                 </a:solidFill>
                 <a:latin typeface="Calibri"/>
               </a:rPr>
-              <a:t>Số liệu khách</a:t>
+              <a:t>Cloud 24/7</a:t>
             </a:r>
           </a:p>
         </p:txBody>
@@ -11726,7 +11726,7 @@
                 </a:solidFill>
                 <a:latin typeface="Calibri"/>
               </a:rPr>
-              <a:t>06/10</a:t>
+              <a:t>16/10</a:t>
             </a:r>
           </a:p>
         </p:txBody>
@@ -11768,7 +11768,7 @@
                 </a:solidFill>
                 <a:latin typeface="Calibri"/>
               </a:rPr>
-              <a:t>v1.4.0</a:t>
+              <a:t>v3.0.0</a:t>
             </a:r>
           </a:p>
         </p:txBody>
@@ -11810,7 +11810,7 @@
                 </a:solidFill>
                 <a:latin typeface="Calibri"/>
               </a:rPr>
-              <a:t>11 góp ý Mentor</a:t>
+              <a:t>Lotus Ivory $10k</a:t>
             </a:r>
           </a:p>
         </p:txBody>

</xml_diff>